<commit_message>
Add security depth across the course + trainer-side updates
Course: design-time threat modeling (Lab 2d, ADR Threats table), where
secrets should live + compliance note (M6), prompt-injection gotcha and
supply-chain lab 7e (M7), signed tags + artifact digests / Lab 8e (M8),
new post-release appendix (CVE watch, hotfix drill). Entry-flow fixes:
env prereqs in Module 0, spoiler warning on the answer key.

Trainer side: instructor guide run-sheet beats, tag-signing failure-kit
entry, take-home pointers, rubric row; pilot run-sheet rows 2/8; slide
deck regenerated (Modules 2/7/8 anchors). Kit design-reviewer prompt
gains the attacker question.

Co-Authored-By: Claude Fable 5 <noreply@anthropic.com>
</commit_message>
<xml_diff>
--- a/instructor/slides/cc-masterclass-deck.pptx
+++ b/instructor/slides/cc-masterclass-deck.pptx
@@ -5592,7 +5592,7 @@
                 <a:ea typeface="Calibri" pitchFamily="34" charset="-122"/>
                 <a:cs typeface="Calibri" pitchFamily="34" charset="-120"/>
               </a:rPr>
-              <a:t>Objective oracle + sandbox + audit log make unattended autonomy genuinely safe here.</a:t>
+              <a:t>Objective oracle + sandbox + audit log make unattended autonomy genuinely safe here — but a CI agent reads attacker-controlled PRs: scope its tools, keep merge authority human.</a:t>
             </a:r>
             <a:endParaRPr lang="en-US" sz="1600" dirty="0"/>
           </a:p>
@@ -5705,7 +5705,7 @@
                 <a:ea typeface="Calibri" pitchFamily="34" charset="-122"/>
                 <a:cs typeface="Calibri" pitchFamily="34" charset="-120"/>
               </a:rPr>
-              <a:t>Headless claude -p · build-fixer loop · /code-review · CI bot</a:t>
+              <a:t>Headless claude -p · build-fixer loop · /code-review · CI bot · injection guardrails · supply chain</a:t>
             </a:r>
             <a:endParaRPr lang="en-US" sz="1500" dirty="0"/>
           </a:p>
@@ -6203,7 +6203,7 @@
                 <a:ea typeface="Calibri" pitchFamily="34" charset="-122"/>
                 <a:cs typeface="Calibri" pitchFamily="34" charset="-120"/>
               </a:rPr>
-              <a:t>Notes, changelog, and tag checks are delegable; the go/no-go to ship stays human.</a:t>
+              <a:t>Notes, changelog, and tag checks are delegable; the go/no-go to ship stays human — and what ships is signed.</a:t>
             </a:r>
             <a:endParaRPr lang="en-US" sz="1600" dirty="0"/>
           </a:p>
@@ -6316,7 +6316,7 @@
                 <a:ea typeface="Calibri" pitchFamily="34" charset="-122"/>
                 <a:cs typeface="Calibri" pitchFamily="34" charset="-120"/>
               </a:rPr>
-              <a:t>release-notes skill · semver hook · /schedule</a:t>
+              <a:t>release-notes skill · semver hook · signed tag + digests · /schedule</a:t>
             </a:r>
             <a:endParaRPr lang="en-US" sz="1500" dirty="0"/>
           </a:p>
@@ -6420,7 +6420,7 @@
                 <a:ea typeface="Calibri" pitchFamily="34" charset="-122"/>
                 <a:cs typeface="Calibri" pitchFamily="34" charset="-120"/>
               </a:rPr>
-              <a:t>Cut v1.1.0: the agent drafts notes from commits, you approve the tag.</a:t>
+              <a:t>Cut v1.1.0: the agent drafts notes from commits, you approve and sign the tag.</a:t>
             </a:r>
             <a:endParaRPr lang="en-US" sz="1450" dirty="0"/>
           </a:p>
@@ -22636,7 +22636,7 @@
                 <a:ea typeface="Calibri" pitchFamily="34" charset="-122"/>
                 <a:cs typeface="Calibri" pitchFamily="34" charset="-120"/>
               </a:rPr>
-              <a:t>Read-only exploration returns conclusions, not file dumps; the decision earns a durable ADR.</a:t>
+              <a:t>Read-only exploration returns conclusions, not file dumps; the decision earns a durable ADR — threats included, while the design is still cheap to change.</a:t>
             </a:r>
             <a:endParaRPr lang="en-US" sz="1600" dirty="0"/>
           </a:p>
@@ -22749,7 +22749,7 @@
                 <a:ea typeface="Calibri" pitchFamily="34" charset="-122"/>
                 <a:cs typeface="Calibri" pitchFamily="34" charset="-120"/>
               </a:rPr>
-              <a:t>Explore / Plan sub-agents · plan mode · ADRs</a:t>
+              <a:t>Explore / Plan sub-agents · plan mode · ADRs · threat model</a:t>
             </a:r>
             <a:endParaRPr lang="en-US" sz="1500" dirty="0"/>
           </a:p>
@@ -22853,7 +22853,7 @@
                 <a:ea typeface="Calibri" pitchFamily="34" charset="-122"/>
                 <a:cs typeface="Calibri" pitchFamily="34" charset="-120"/>
               </a:rPr>
-              <a:t>Design the CRC change; a design-reviewer sub-agent critiques the ADR before you commit.</a:t>
+              <a:t>Design the CRC change; threat-model the frame (CRC ≠ tamper-proofing); a design-reviewer sub-agent critiques the ADR.</a:t>
             </a:r>
             <a:endParaRPr lang="en-US" sz="1450" dirty="0"/>
           </a:p>

</xml_diff>